<commit_message>
Add demo video (docs/ResolveAI_demo.mp4, https://youtu.be/eRBRi4PisPU) to the repo, deck and README
- Earlier API walkthrough video docs/demo.webm kept
- Deck slides 5 and 11 carry the YouTube link; URLs in the deck are clickable
</commit_message>
<xml_diff>
--- a/docs/VITV_ResolveAI_Submission.pptx
+++ b/docs/VITV_ResolveAI_Submission.pptx
@@ -13375,7 +13375,24 @@
                   <a:srgbClr val="14142B"/>
                 </a:solidFill>
               </a:rPr>
-              <a:t> https://github.com/shashi-bhushan-27/samsungPrism  (tag PRISM_GENAI_HACKATHON_Y2026)</a:t>
+              <a:t> </a:t>
+            </a:r>
+            <a:r>
+              <a:rPr sz="1600" b="0">
+                <a:solidFill>
+                  <a:srgbClr val="14142B"/>
+                </a:solidFill>
+                <a:hlinkClick r:id="rId4"/>
+              </a:rPr>
+              <a:t>https://github.com/shashi-bhushan-27/samsungPrism</a:t>
+            </a:r>
+            <a:r>
+              <a:rPr sz="1600" b="0">
+                <a:solidFill>
+                  <a:srgbClr val="14142B"/>
+                </a:solidFill>
+              </a:rPr>
+              <a:t>  (tag PRISM_GENAI_HACKATHON_Y2026)</a:t>
             </a:r>
             <a:endParaRPr/>
           </a:p>
@@ -13852,7 +13869,24 @@
                   <a:srgbClr val="14142B"/>
                 </a:solidFill>
               </a:rPr>
-              <a:t> (https://github.com/shashi-bhushan-27/samsungPrism)</a:t>
+              <a:t> (</a:t>
+            </a:r>
+            <a:r>
+              <a:rPr sz="1700" b="0">
+                <a:solidFill>
+                  <a:srgbClr val="14142B"/>
+                </a:solidFill>
+                <a:hlinkClick r:id="rId3"/>
+              </a:rPr>
+              <a:t>https://github.com/shashi-bhushan-27/samsungPrism</a:t>
+            </a:r>
+            <a:r>
+              <a:rPr sz="1700" b="0">
+                <a:solidFill>
+                  <a:srgbClr val="14142B"/>
+                </a:solidFill>
+              </a:rPr>
+              <a:t>)</a:t>
             </a:r>
             <a:endParaRPr sz="2800"/>
           </a:p>
@@ -13915,7 +13949,24 @@
                   <a:srgbClr val="14142B"/>
                 </a:solidFill>
               </a:rPr>
-              <a:t> (docs/demo.webm)  [TO FILL: YouTube or Drive link]</a:t>
+              <a:t> (</a:t>
+            </a:r>
+            <a:r>
+              <a:rPr sz="1700" b="0">
+                <a:solidFill>
+                  <a:srgbClr val="14142B"/>
+                </a:solidFill>
+                <a:hlinkClick r:id="rId4"/>
+              </a:rPr>
+              <a:t>https://youtu.be/eRBRi4PisPU</a:t>
+            </a:r>
+            <a:r>
+              <a:rPr sz="1700" b="0">
+                <a:solidFill>
+                  <a:srgbClr val="14142B"/>
+                </a:solidFill>
+              </a:rPr>
+              <a:t>; docs/ResolveAI_demo.mp4, docs/demo.webm)</a:t>
             </a:r>
           </a:p>
           <a:p>
@@ -16167,7 +16218,24 @@
                   <a:srgbClr val="14142B"/>
                 </a:solidFill>
               </a:rPr>
-              <a:t> docs/demo.webm in the repository  [TO FILL: YouTube / Drive link]</a:t>
+              <a:t> </a:t>
+            </a:r>
+            <a:r>
+              <a:rPr sz="1400" b="0">
+                <a:solidFill>
+                  <a:srgbClr val="14142B"/>
+                </a:solidFill>
+                <a:hlinkClick r:id="rId4"/>
+              </a:rPr>
+              <a:t>https://youtu.be/eRBRi4PisPU</a:t>
+            </a:r>
+            <a:r>
+              <a:rPr sz="1400" b="0">
+                <a:solidFill>
+                  <a:srgbClr val="14142B"/>
+                </a:solidFill>
+              </a:rPr>
+              <a:t> (also docs/ResolveAI_demo.mp4; earlier API walkthrough: docs/demo.webm)</a:t>
             </a:r>
             <a:endParaRPr/>
           </a:p>

</xml_diff>